<commit_message>
Avoid redundant resident confirmations across bot and app
</commit_message>
<xml_diff>
--- a/submission/DomPuls_MAX_hackathon.pptx
+++ b/submission/DomPuls_MAX_hackathon.pptx
@@ -2,20 +2,20 @@
 <file path=ppt/presentation.xml><?xml version="1.0" encoding="utf-8"?>
 <p:presentation xmlns:p="http://schemas.openxmlformats.org/presentationml/2006/main">
   <p:sldMasterIdLst>
-    <p:sldMasterId xmlns:r="http://schemas.openxmlformats.org/officeDocument/2006/relationships" id="2147483648" r:id="R868365a8ffc348ad"/>
+    <p:sldMasterId xmlns:r="http://schemas.openxmlformats.org/officeDocument/2006/relationships" id="2147483648" r:id="R6436424501904492"/>
   </p:sldMasterIdLst>
   <p:notesMasterIdLst>
-    <p:notesMasterId xmlns:r="http://schemas.openxmlformats.org/officeDocument/2006/relationships" r:id="R4fbfcfaeaff0478b"/>
+    <p:notesMasterId xmlns:r="http://schemas.openxmlformats.org/officeDocument/2006/relationships" r:id="Rce2251e6374244b5"/>
   </p:notesMasterIdLst>
   <p:sldIdLst>
-    <p:sldId xmlns:r="http://schemas.openxmlformats.org/officeDocument/2006/relationships" id="256" r:id="Rd621bff17cde4156"/>
-    <p:sldId xmlns:r="http://schemas.openxmlformats.org/officeDocument/2006/relationships" id="257" r:id="R1b4a1e2b0f4f4c22"/>
-    <p:sldId xmlns:r="http://schemas.openxmlformats.org/officeDocument/2006/relationships" id="258" r:id="R89f2c234b6fc4221"/>
-    <p:sldId xmlns:r="http://schemas.openxmlformats.org/officeDocument/2006/relationships" id="259" r:id="R7eb1fc3051dd44fa"/>
-    <p:sldId xmlns:r="http://schemas.openxmlformats.org/officeDocument/2006/relationships" id="260" r:id="Raed653c147264094"/>
-    <p:sldId xmlns:r="http://schemas.openxmlformats.org/officeDocument/2006/relationships" id="261" r:id="R04a3dbccba8e4728"/>
-    <p:sldId xmlns:r="http://schemas.openxmlformats.org/officeDocument/2006/relationships" id="262" r:id="R7782bddc55744a46"/>
-    <p:sldId xmlns:r="http://schemas.openxmlformats.org/officeDocument/2006/relationships" id="263" r:id="Rb7c90d17849d46b1"/>
+    <p:sldId xmlns:r="http://schemas.openxmlformats.org/officeDocument/2006/relationships" id="256" r:id="R84352d1968734e30"/>
+    <p:sldId xmlns:r="http://schemas.openxmlformats.org/officeDocument/2006/relationships" id="257" r:id="R57946a38e0fb4c9e"/>
+    <p:sldId xmlns:r="http://schemas.openxmlformats.org/officeDocument/2006/relationships" id="258" r:id="R3c5db912042b4cfa"/>
+    <p:sldId xmlns:r="http://schemas.openxmlformats.org/officeDocument/2006/relationships" id="259" r:id="Rb71f59677ded4641"/>
+    <p:sldId xmlns:r="http://schemas.openxmlformats.org/officeDocument/2006/relationships" id="260" r:id="R4b4d18a069a24f17"/>
+    <p:sldId xmlns:r="http://schemas.openxmlformats.org/officeDocument/2006/relationships" id="261" r:id="R94cac002abfd4efe"/>
+    <p:sldId xmlns:r="http://schemas.openxmlformats.org/officeDocument/2006/relationships" id="262" r:id="Rdc0028829e2e457d"/>
+    <p:sldId xmlns:r="http://schemas.openxmlformats.org/officeDocument/2006/relationships" id="263" r:id="Ra2076263e9de4cd9"/>
   </p:sldIdLst>
   <p:sldSz cx="12192000" cy="6858000"/>
   <p:notesSz cx="6858000" cy="9144000"/>
@@ -1007,7 +1007,7 @@
   </p:cSld>
   <p:clrMap bg1="lt1" tx1="dk1" bg2="lt2" tx2="dk2" accent1="accent1" accent2="accent2" accent3="accent3" accent4="accent4" accent5="accent5" accent6="accent6" hlink="hlink" folHlink="folHlink"/>
   <p:sldLayoutIdLst>
-    <p:sldLayoutId xmlns:r="http://schemas.openxmlformats.org/officeDocument/2006/relationships" id="2147483649" r:id="R9e5f71624df94629"/>
+    <p:sldLayoutId xmlns:r="http://schemas.openxmlformats.org/officeDocument/2006/relationships" id="2147483649" r:id="Ref67b257649741e0"/>
   </p:sldLayoutIdLst>
   <p:txStyles>
     <p:titleStyle>
@@ -1558,7 +1558,7 @@
           <p:cNvPr id="6" name="">
             <a:extLst xmlns:a="http://schemas.openxmlformats.org/drawingml/2006/main">
               <a:ext uri="{FF2B5EF4-FFF2-40B4-BE49-F238E27FC236}">
-                <a16:creationId xmlns:a16="http://schemas.microsoft.com/office/drawing/2014/main" id="{7A344564-7030-4C03-99C3-44F2DA14BBAC}"/>
+                <a16:creationId xmlns:a16="http://schemas.microsoft.com/office/drawing/2014/main" id="{01EDB9E2-6B31-4327-BE53-9E7A170FA3E9}"/>
               </a:ext>
             </a:extLst>
           </p:cNvPr>
@@ -1615,7 +1615,7 @@
           <p:cNvPr id="2" name="">
             <a:extLst xmlns:a="http://schemas.openxmlformats.org/drawingml/2006/main">
               <a:ext uri="{FF2B5EF4-FFF2-40B4-BE49-F238E27FC236}">
-                <a16:creationId xmlns:a16="http://schemas.microsoft.com/office/drawing/2014/main" id="{0F6D830C-9F30-43DA-B97F-20A0C744B63F}"/>
+                <a16:creationId xmlns:a16="http://schemas.microsoft.com/office/drawing/2014/main" id="{108C8D1B-51BF-4762-B6AE-532A4E3E9CE4}"/>
               </a:ext>
             </a:extLst>
           </p:cNvPr>
@@ -1672,7 +1672,7 @@
           <p:cNvPr id="3" name="">
             <a:extLst xmlns:a="http://schemas.openxmlformats.org/drawingml/2006/main">
               <a:ext uri="{FF2B5EF4-FFF2-40B4-BE49-F238E27FC236}">
-                <a16:creationId xmlns:a16="http://schemas.microsoft.com/office/drawing/2014/main" id="{6E98048A-9EF4-496C-949D-914E1D5E48CF}"/>
+                <a16:creationId xmlns:a16="http://schemas.microsoft.com/office/drawing/2014/main" id="{7677E7FA-3839-4BD5-B59A-6E4B9D6B11EE}"/>
               </a:ext>
             </a:extLst>
           </p:cNvPr>
@@ -1752,7 +1752,7 @@
           <p:cNvPr id="4" name="">
             <a:extLst xmlns:a="http://schemas.openxmlformats.org/drawingml/2006/main">
               <a:ext uri="{FF2B5EF4-FFF2-40B4-BE49-F238E27FC236}">
-                <a16:creationId xmlns:a16="http://schemas.microsoft.com/office/drawing/2014/main" id="{6B07484C-FA41-43B9-9DDF-5011D77E1409}"/>
+                <a16:creationId xmlns:a16="http://schemas.microsoft.com/office/drawing/2014/main" id="{CD2E01D3-8E99-43E1-878A-DFA8F2271278}"/>
               </a:ext>
             </a:extLst>
           </p:cNvPr>
@@ -1813,7 +1813,7 @@
           <p:nvPr/>
         </p:nvPicPr>
         <p:blipFill>
-          <a:blip xmlns:r="http://schemas.openxmlformats.org/officeDocument/2006/relationships" xmlns:a="http://schemas.openxmlformats.org/drawingml/2006/main" r:embed="R8ce662ab8ee74006"/>
+          <a:blip xmlns:r="http://schemas.openxmlformats.org/officeDocument/2006/relationships" xmlns:a="http://schemas.openxmlformats.org/drawingml/2006/main" r:embed="R217c24780dba4c5e"/>
           <a:stretch xmlns:a="http://schemas.openxmlformats.org/drawingml/2006/main"/>
         </p:blipFill>
         <p:spPr>
@@ -1829,7 +1829,7 @@
     </p:spTree>
     <p:extLst>
       <p:ext uri="{BB962C8B-B14F-4D97-AF65-F5344CB8AC3E}">
-        <p14:creationId xmlns:p14="http://schemas.microsoft.com/office/powerpoint/2010/main" val="46932261"/>
+        <p14:creationId xmlns:p14="http://schemas.microsoft.com/office/powerpoint/2010/main" val="2121573203"/>
       </p:ext>
     </p:extLst>
   </p:cSld>
@@ -1860,7 +1860,7 @@
           <p:cNvPr id="8" name="">
             <a:extLst xmlns:a="http://schemas.openxmlformats.org/drawingml/2006/main">
               <a:ext uri="{FF2B5EF4-FFF2-40B4-BE49-F238E27FC236}">
-                <a16:creationId xmlns:a16="http://schemas.microsoft.com/office/drawing/2014/main" id="{62649633-9414-462F-9990-BB3CF5ECC735}"/>
+                <a16:creationId xmlns:a16="http://schemas.microsoft.com/office/drawing/2014/main" id="{92B7BEFD-BF2C-4BF6-9615-2771AC4AE87C}"/>
               </a:ext>
             </a:extLst>
           </p:cNvPr>
@@ -1917,7 +1917,7 @@
           <p:cNvPr id="2" name="">
             <a:extLst xmlns:a="http://schemas.openxmlformats.org/drawingml/2006/main">
               <a:ext uri="{FF2B5EF4-FFF2-40B4-BE49-F238E27FC236}">
-                <a16:creationId xmlns:a16="http://schemas.microsoft.com/office/drawing/2014/main" id="{AE430379-4DA2-4D1D-9BDD-82CA5F306238}"/>
+                <a16:creationId xmlns:a16="http://schemas.microsoft.com/office/drawing/2014/main" id="{4E935BE7-537A-4C34-937B-79AEF8BB31F8}"/>
               </a:ext>
             </a:extLst>
           </p:cNvPr>
@@ -1974,7 +1974,7 @@
           <p:cNvPr id="3" name="">
             <a:extLst xmlns:a="http://schemas.openxmlformats.org/drawingml/2006/main">
               <a:ext uri="{FF2B5EF4-FFF2-40B4-BE49-F238E27FC236}">
-                <a16:creationId xmlns:a16="http://schemas.microsoft.com/office/drawing/2014/main" id="{067F578D-FA38-49E6-BDDC-85710BDED5EF}"/>
+                <a16:creationId xmlns:a16="http://schemas.microsoft.com/office/drawing/2014/main" id="{93737FE2-F434-46A3-AD80-6A880D1DED0E}"/>
               </a:ext>
             </a:extLst>
           </p:cNvPr>
@@ -2031,7 +2031,7 @@
           <p:cNvPr id="4" name="">
             <a:extLst xmlns:a="http://schemas.openxmlformats.org/drawingml/2006/main">
               <a:ext uri="{FF2B5EF4-FFF2-40B4-BE49-F238E27FC236}">
-                <a16:creationId xmlns:a16="http://schemas.microsoft.com/office/drawing/2014/main" id="{B20A2B07-357F-4D8D-B4E0-F9AC94295EC5}"/>
+                <a16:creationId xmlns:a16="http://schemas.microsoft.com/office/drawing/2014/main" id="{4F7CA001-C63A-4139-8E79-AF0BCFE4661A}"/>
               </a:ext>
             </a:extLst>
           </p:cNvPr>
@@ -2088,7 +2088,7 @@
           <p:cNvPr id="5" name="">
             <a:extLst xmlns:a="http://schemas.openxmlformats.org/drawingml/2006/main">
               <a:ext uri="{FF2B5EF4-FFF2-40B4-BE49-F238E27FC236}">
-                <a16:creationId xmlns:a16="http://schemas.microsoft.com/office/drawing/2014/main" id="{EE74EAA2-A05D-4357-913F-40B4CA8E3181}"/>
+                <a16:creationId xmlns:a16="http://schemas.microsoft.com/office/drawing/2014/main" id="{ADFA6DDA-A87A-4F92-A815-A52A2544DDC1}"/>
               </a:ext>
             </a:extLst>
           </p:cNvPr>
@@ -2145,7 +2145,7 @@
           <p:cNvPr id="6" name="">
             <a:extLst xmlns:a="http://schemas.openxmlformats.org/drawingml/2006/main">
               <a:ext uri="{FF2B5EF4-FFF2-40B4-BE49-F238E27FC236}">
-                <a16:creationId xmlns:a16="http://schemas.microsoft.com/office/drawing/2014/main" id="{D0683B8B-B353-4DAF-A988-586B51CF0AEA}"/>
+                <a16:creationId xmlns:a16="http://schemas.microsoft.com/office/drawing/2014/main" id="{6A859B1D-17B1-45A6-932E-CCF6B10AC521}"/>
               </a:ext>
             </a:extLst>
           </p:cNvPr>
@@ -2206,7 +2206,7 @@
           <p:nvPr/>
         </p:nvPicPr>
         <p:blipFill>
-          <a:blip xmlns:r="http://schemas.openxmlformats.org/officeDocument/2006/relationships" xmlns:a="http://schemas.openxmlformats.org/drawingml/2006/main" r:embed="Rd92c3a95f65646a7"/>
+          <a:blip xmlns:r="http://schemas.openxmlformats.org/officeDocument/2006/relationships" xmlns:a="http://schemas.openxmlformats.org/drawingml/2006/main" r:embed="Raa5a816bc8b64587"/>
           <a:stretch xmlns:a="http://schemas.openxmlformats.org/drawingml/2006/main"/>
         </p:blipFill>
         <p:spPr>
@@ -2222,7 +2222,7 @@
     </p:spTree>
     <p:extLst>
       <p:ext uri="{BB962C8B-B14F-4D97-AF65-F5344CB8AC3E}">
-        <p14:creationId xmlns:p14="http://schemas.microsoft.com/office/powerpoint/2010/main" val="978662648"/>
+        <p14:creationId xmlns:p14="http://schemas.microsoft.com/office/powerpoint/2010/main" val="555657575"/>
       </p:ext>
     </p:extLst>
   </p:cSld>
@@ -2253,7 +2253,7 @@
           <p:cNvPr id="17" name="">
             <a:extLst xmlns:a="http://schemas.openxmlformats.org/drawingml/2006/main">
               <a:ext uri="{FF2B5EF4-FFF2-40B4-BE49-F238E27FC236}">
-                <a16:creationId xmlns:a16="http://schemas.microsoft.com/office/drawing/2014/main" id="{749BDCBB-602B-49BE-AF21-4F6F9BAE6C3C}"/>
+                <a16:creationId xmlns:a16="http://schemas.microsoft.com/office/drawing/2014/main" id="{CCADDFB0-489A-4337-8C30-D087F9E6C281}"/>
               </a:ext>
             </a:extLst>
           </p:cNvPr>
@@ -2310,7 +2310,7 @@
           <p:cNvPr id="2" name="">
             <a:extLst xmlns:a="http://schemas.openxmlformats.org/drawingml/2006/main">
               <a:ext uri="{FF2B5EF4-FFF2-40B4-BE49-F238E27FC236}">
-                <a16:creationId xmlns:a16="http://schemas.microsoft.com/office/drawing/2014/main" id="{9116530F-3FF9-4049-85C6-3A5BDC996B94}"/>
+                <a16:creationId xmlns:a16="http://schemas.microsoft.com/office/drawing/2014/main" id="{223416CC-F6FD-4BE9-B831-59F7C4DFD5C2}"/>
               </a:ext>
             </a:extLst>
           </p:cNvPr>
@@ -2367,7 +2367,7 @@
           <p:cNvPr id="3" name="">
             <a:extLst xmlns:a="http://schemas.openxmlformats.org/drawingml/2006/main">
               <a:ext uri="{FF2B5EF4-FFF2-40B4-BE49-F238E27FC236}">
-                <a16:creationId xmlns:a16="http://schemas.microsoft.com/office/drawing/2014/main" id="{6AE1B6B7-6EA3-4444-B51D-0A457685C2E5}"/>
+                <a16:creationId xmlns:a16="http://schemas.microsoft.com/office/drawing/2014/main" id="{AE120318-105C-4BA9-AFED-1E6026E942C5}"/>
               </a:ext>
             </a:extLst>
           </p:cNvPr>
@@ -2424,7 +2424,7 @@
           <p:cNvPr id="4" name="">
             <a:extLst xmlns:a="http://schemas.openxmlformats.org/drawingml/2006/main">
               <a:ext uri="{FF2B5EF4-FFF2-40B4-BE49-F238E27FC236}">
-                <a16:creationId xmlns:a16="http://schemas.microsoft.com/office/drawing/2014/main" id="{6D1DB72A-63C8-4773-B12B-431F0C1A086A}"/>
+                <a16:creationId xmlns:a16="http://schemas.microsoft.com/office/drawing/2014/main" id="{845E3529-4EA7-4715-859C-05A46C0BCD22}"/>
               </a:ext>
             </a:extLst>
           </p:cNvPr>
@@ -2481,7 +2481,7 @@
           <p:cNvPr id="5" name="">
             <a:extLst xmlns:a="http://schemas.openxmlformats.org/drawingml/2006/main">
               <a:ext uri="{FF2B5EF4-FFF2-40B4-BE49-F238E27FC236}">
-                <a16:creationId xmlns:a16="http://schemas.microsoft.com/office/drawing/2014/main" id="{BF6A8D1B-AF0D-4DEE-9161-C7EBD38F2C95}"/>
+                <a16:creationId xmlns:a16="http://schemas.microsoft.com/office/drawing/2014/main" id="{CB6F9B09-8E6A-43AE-972B-5482CA4D2CC2}"/>
               </a:ext>
             </a:extLst>
           </p:cNvPr>
@@ -2538,7 +2538,7 @@
           <p:cNvPr id="6" name="">
             <a:extLst xmlns:a="http://schemas.openxmlformats.org/drawingml/2006/main">
               <a:ext uri="{FF2B5EF4-FFF2-40B4-BE49-F238E27FC236}">
-                <a16:creationId xmlns:a16="http://schemas.microsoft.com/office/drawing/2014/main" id="{5F2256EA-7325-422A-ACE5-C419DE712179}"/>
+                <a16:creationId xmlns:a16="http://schemas.microsoft.com/office/drawing/2014/main" id="{D40C70A6-6849-4605-9E73-8403100A0659}"/>
               </a:ext>
             </a:extLst>
           </p:cNvPr>
@@ -2618,7 +2618,7 @@
           <p:cNvPr id="7" name="">
             <a:extLst xmlns:a="http://schemas.openxmlformats.org/drawingml/2006/main">
               <a:ext uri="{FF2B5EF4-FFF2-40B4-BE49-F238E27FC236}">
-                <a16:creationId xmlns:a16="http://schemas.microsoft.com/office/drawing/2014/main" id="{56B97F3F-82DD-4610-BD82-3C718B2464AF}"/>
+                <a16:creationId xmlns:a16="http://schemas.microsoft.com/office/drawing/2014/main" id="{2E9A23EF-DA79-4B1D-A3BF-A36E65514463}"/>
               </a:ext>
             </a:extLst>
           </p:cNvPr>
@@ -2675,7 +2675,7 @@
           <p:cNvPr id="8" name="">
             <a:extLst xmlns:a="http://schemas.openxmlformats.org/drawingml/2006/main">
               <a:ext uri="{FF2B5EF4-FFF2-40B4-BE49-F238E27FC236}">
-                <a16:creationId xmlns:a16="http://schemas.microsoft.com/office/drawing/2014/main" id="{05BA1189-DDAA-4A62-9EDD-67502AE42410}"/>
+                <a16:creationId xmlns:a16="http://schemas.microsoft.com/office/drawing/2014/main" id="{84CE40D2-93CC-46BE-9270-F9B241DB43D4}"/>
               </a:ext>
             </a:extLst>
           </p:cNvPr>
@@ -2732,7 +2732,7 @@
           <p:cNvPr id="9" name="">
             <a:extLst xmlns:a="http://schemas.openxmlformats.org/drawingml/2006/main">
               <a:ext uri="{FF2B5EF4-FFF2-40B4-BE49-F238E27FC236}">
-                <a16:creationId xmlns:a16="http://schemas.microsoft.com/office/drawing/2014/main" id="{C78DC3C5-35D9-4196-B93B-EF28A1323510}"/>
+                <a16:creationId xmlns:a16="http://schemas.microsoft.com/office/drawing/2014/main" id="{554BF10B-3962-408E-9D6A-908FE357937B}"/>
               </a:ext>
             </a:extLst>
           </p:cNvPr>
@@ -2812,7 +2812,7 @@
           <p:cNvPr id="10" name="">
             <a:extLst xmlns:a="http://schemas.openxmlformats.org/drawingml/2006/main">
               <a:ext uri="{FF2B5EF4-FFF2-40B4-BE49-F238E27FC236}">
-                <a16:creationId xmlns:a16="http://schemas.microsoft.com/office/drawing/2014/main" id="{C1787BB2-4C3F-4708-A374-2493545ECBA3}"/>
+                <a16:creationId xmlns:a16="http://schemas.microsoft.com/office/drawing/2014/main" id="{EA9C4829-8773-4760-9891-F0240B66AD66}"/>
               </a:ext>
             </a:extLst>
           </p:cNvPr>
@@ -2869,7 +2869,7 @@
           <p:cNvPr id="11" name="">
             <a:extLst xmlns:a="http://schemas.openxmlformats.org/drawingml/2006/main">
               <a:ext uri="{FF2B5EF4-FFF2-40B4-BE49-F238E27FC236}">
-                <a16:creationId xmlns:a16="http://schemas.microsoft.com/office/drawing/2014/main" id="{7C5933E3-124F-47CB-A60D-5DFB5C437C22}"/>
+                <a16:creationId xmlns:a16="http://schemas.microsoft.com/office/drawing/2014/main" id="{8D878437-9CAE-4C39-9C2F-2AF7615A2857}"/>
               </a:ext>
             </a:extLst>
           </p:cNvPr>
@@ -2926,7 +2926,7 @@
           <p:cNvPr id="12" name="">
             <a:extLst xmlns:a="http://schemas.openxmlformats.org/drawingml/2006/main">
               <a:ext uri="{FF2B5EF4-FFF2-40B4-BE49-F238E27FC236}">
-                <a16:creationId xmlns:a16="http://schemas.microsoft.com/office/drawing/2014/main" id="{E171F126-E4CC-4E7A-AC9F-E65E1B98FB0C}"/>
+                <a16:creationId xmlns:a16="http://schemas.microsoft.com/office/drawing/2014/main" id="{22339422-D33E-4042-90A0-A81F21CC0544}"/>
               </a:ext>
             </a:extLst>
           </p:cNvPr>
@@ -3006,7 +3006,7 @@
           <p:cNvPr id="13" name="">
             <a:extLst xmlns:a="http://schemas.openxmlformats.org/drawingml/2006/main">
               <a:ext uri="{FF2B5EF4-FFF2-40B4-BE49-F238E27FC236}">
-                <a16:creationId xmlns:a16="http://schemas.microsoft.com/office/drawing/2014/main" id="{4CC97C31-13D6-4E88-8A61-DF714A7E9ACE}"/>
+                <a16:creationId xmlns:a16="http://schemas.microsoft.com/office/drawing/2014/main" id="{348F4885-BB76-46BB-A929-8B7A522F240D}"/>
               </a:ext>
             </a:extLst>
           </p:cNvPr>
@@ -3063,7 +3063,7 @@
           <p:cNvPr id="14" name="">
             <a:extLst xmlns:a="http://schemas.openxmlformats.org/drawingml/2006/main">
               <a:ext uri="{FF2B5EF4-FFF2-40B4-BE49-F238E27FC236}">
-                <a16:creationId xmlns:a16="http://schemas.microsoft.com/office/drawing/2014/main" id="{0E2F1527-02C5-42FB-AEB6-5969C52BAC70}"/>
+                <a16:creationId xmlns:a16="http://schemas.microsoft.com/office/drawing/2014/main" id="{3C583661-5CC3-4CF2-8570-84E2F5B548FD}"/>
               </a:ext>
             </a:extLst>
           </p:cNvPr>
@@ -3120,7 +3120,7 @@
           <p:cNvPr id="15" name="">
             <a:extLst xmlns:a="http://schemas.openxmlformats.org/drawingml/2006/main">
               <a:ext uri="{FF2B5EF4-FFF2-40B4-BE49-F238E27FC236}">
-                <a16:creationId xmlns:a16="http://schemas.microsoft.com/office/drawing/2014/main" id="{3FF3577A-EC28-4788-9A9C-D6B26AA63C97}"/>
+                <a16:creationId xmlns:a16="http://schemas.microsoft.com/office/drawing/2014/main" id="{B618393B-A1EF-4864-98BC-018D0EBAD754}"/>
               </a:ext>
             </a:extLst>
           </p:cNvPr>
@@ -3200,7 +3200,7 @@
           <p:cNvPr id="16" name="">
             <a:extLst xmlns:a="http://schemas.openxmlformats.org/drawingml/2006/main">
               <a:ext uri="{FF2B5EF4-FFF2-40B4-BE49-F238E27FC236}">
-                <a16:creationId xmlns:a16="http://schemas.microsoft.com/office/drawing/2014/main" id="{F3A38326-6AFF-404D-A7D9-13406C03D997}"/>
+                <a16:creationId xmlns:a16="http://schemas.microsoft.com/office/drawing/2014/main" id="{63300ADB-4E34-4422-9FB9-58481F1BD085}"/>
               </a:ext>
             </a:extLst>
           </p:cNvPr>
@@ -3255,7 +3255,7 @@
     </p:spTree>
     <p:extLst>
       <p:ext uri="{BB962C8B-B14F-4D97-AF65-F5344CB8AC3E}">
-        <p14:creationId xmlns:p14="http://schemas.microsoft.com/office/powerpoint/2010/main" val="51271543"/>
+        <p14:creationId xmlns:p14="http://schemas.microsoft.com/office/powerpoint/2010/main" val="1249361705"/>
       </p:ext>
     </p:extLst>
   </p:cSld>
@@ -3286,7 +3286,7 @@
           <p:cNvPr id="12" name="">
             <a:extLst xmlns:a="http://schemas.openxmlformats.org/drawingml/2006/main">
               <a:ext uri="{FF2B5EF4-FFF2-40B4-BE49-F238E27FC236}">
-                <a16:creationId xmlns:a16="http://schemas.microsoft.com/office/drawing/2014/main" id="{C151F5CF-7116-471B-A9AA-D4CA7A5D1B18}"/>
+                <a16:creationId xmlns:a16="http://schemas.microsoft.com/office/drawing/2014/main" id="{C8C84BB2-0569-4E07-B370-8E2B355EC0EB}"/>
               </a:ext>
             </a:extLst>
           </p:cNvPr>
@@ -3343,7 +3343,7 @@
           <p:cNvPr id="2" name="">
             <a:extLst xmlns:a="http://schemas.openxmlformats.org/drawingml/2006/main">
               <a:ext uri="{FF2B5EF4-FFF2-40B4-BE49-F238E27FC236}">
-                <a16:creationId xmlns:a16="http://schemas.microsoft.com/office/drawing/2014/main" id="{2ACAFF52-36BA-459E-B3FB-DEB15EFAF959}"/>
+                <a16:creationId xmlns:a16="http://schemas.microsoft.com/office/drawing/2014/main" id="{06F89625-C473-4E3D-8B8B-420D91C8F685}"/>
               </a:ext>
             </a:extLst>
           </p:cNvPr>
@@ -3400,7 +3400,7 @@
           <p:cNvPr id="3" name="">
             <a:extLst xmlns:a="http://schemas.openxmlformats.org/drawingml/2006/main">
               <a:ext uri="{FF2B5EF4-FFF2-40B4-BE49-F238E27FC236}">
-                <a16:creationId xmlns:a16="http://schemas.microsoft.com/office/drawing/2014/main" id="{98E1D48F-B833-4379-9144-234851446D11}"/>
+                <a16:creationId xmlns:a16="http://schemas.microsoft.com/office/drawing/2014/main" id="{BEFB8DA8-198C-42B2-8073-0A50B802EBD0}"/>
               </a:ext>
             </a:extLst>
           </p:cNvPr>
@@ -3457,7 +3457,7 @@
           <p:cNvPr id="4" name="">
             <a:extLst xmlns:a="http://schemas.openxmlformats.org/drawingml/2006/main">
               <a:ext uri="{FF2B5EF4-FFF2-40B4-BE49-F238E27FC236}">
-                <a16:creationId xmlns:a16="http://schemas.microsoft.com/office/drawing/2014/main" id="{75E0F1E3-257D-4A0D-AAF5-6E27245F4B5A}"/>
+                <a16:creationId xmlns:a16="http://schemas.microsoft.com/office/drawing/2014/main" id="{ED9557F3-1EE6-49F7-9518-B0E369F60197}"/>
               </a:ext>
             </a:extLst>
           </p:cNvPr>
@@ -3514,7 +3514,7 @@
           <p:cNvPr id="5" name="">
             <a:extLst xmlns:a="http://schemas.openxmlformats.org/drawingml/2006/main">
               <a:ext uri="{FF2B5EF4-FFF2-40B4-BE49-F238E27FC236}">
-                <a16:creationId xmlns:a16="http://schemas.microsoft.com/office/drawing/2014/main" id="{2922E5FD-4416-4DC3-A705-970426FF8024}"/>
+                <a16:creationId xmlns:a16="http://schemas.microsoft.com/office/drawing/2014/main" id="{E35D6760-E7A4-414B-8854-4E088616FA97}"/>
               </a:ext>
             </a:extLst>
           </p:cNvPr>
@@ -3571,7 +3571,7 @@
           <p:cNvPr id="6" name="">
             <a:extLst xmlns:a="http://schemas.openxmlformats.org/drawingml/2006/main">
               <a:ext uri="{FF2B5EF4-FFF2-40B4-BE49-F238E27FC236}">
-                <a16:creationId xmlns:a16="http://schemas.microsoft.com/office/drawing/2014/main" id="{7E75F76F-50BA-46D7-8F68-AF9E90BD69B3}"/>
+                <a16:creationId xmlns:a16="http://schemas.microsoft.com/office/drawing/2014/main" id="{A844CA0B-B671-4D52-82AF-A6056A5896C8}"/>
               </a:ext>
             </a:extLst>
           </p:cNvPr>
@@ -3628,7 +3628,7 @@
           <p:cNvPr id="7" name="">
             <a:extLst xmlns:a="http://schemas.openxmlformats.org/drawingml/2006/main">
               <a:ext uri="{FF2B5EF4-FFF2-40B4-BE49-F238E27FC236}">
-                <a16:creationId xmlns:a16="http://schemas.microsoft.com/office/drawing/2014/main" id="{5B7C454F-015B-4242-BA03-6B1A3FD56DF1}"/>
+                <a16:creationId xmlns:a16="http://schemas.microsoft.com/office/drawing/2014/main" id="{A44E5DB5-6976-4157-8EDB-8155288739E6}"/>
               </a:ext>
             </a:extLst>
           </p:cNvPr>
@@ -3685,7 +3685,7 @@
           <p:cNvPr id="8" name="">
             <a:extLst xmlns:a="http://schemas.openxmlformats.org/drawingml/2006/main">
               <a:ext uri="{FF2B5EF4-FFF2-40B4-BE49-F238E27FC236}">
-                <a16:creationId xmlns:a16="http://schemas.microsoft.com/office/drawing/2014/main" id="{B6996B63-1825-47E2-ADDE-E526ABB294BF}"/>
+                <a16:creationId xmlns:a16="http://schemas.microsoft.com/office/drawing/2014/main" id="{C25D82C0-983B-4935-9EF6-55EF58880A81}"/>
               </a:ext>
             </a:extLst>
           </p:cNvPr>
@@ -3742,7 +3742,7 @@
           <p:cNvPr id="9" name="">
             <a:extLst xmlns:a="http://schemas.openxmlformats.org/drawingml/2006/main">
               <a:ext uri="{FF2B5EF4-FFF2-40B4-BE49-F238E27FC236}">
-                <a16:creationId xmlns:a16="http://schemas.microsoft.com/office/drawing/2014/main" id="{239DB4B0-144A-4176-B74B-8C90522A36A3}"/>
+                <a16:creationId xmlns:a16="http://schemas.microsoft.com/office/drawing/2014/main" id="{4BD81F1E-D043-4359-97C1-EE6A05982510}"/>
               </a:ext>
             </a:extLst>
           </p:cNvPr>
@@ -3799,7 +3799,7 @@
           <p:cNvPr id="10" name="">
             <a:extLst xmlns:a="http://schemas.openxmlformats.org/drawingml/2006/main">
               <a:ext uri="{FF2B5EF4-FFF2-40B4-BE49-F238E27FC236}">
-                <a16:creationId xmlns:a16="http://schemas.microsoft.com/office/drawing/2014/main" id="{5D19AF7B-C79E-4614-AA83-446742B86BB0}"/>
+                <a16:creationId xmlns:a16="http://schemas.microsoft.com/office/drawing/2014/main" id="{53BFBB5E-ACE9-44AF-8E9F-3D06C6279DE6}"/>
               </a:ext>
             </a:extLst>
           </p:cNvPr>
@@ -3856,7 +3856,7 @@
           <p:cNvPr id="11" name="">
             <a:extLst xmlns:a="http://schemas.openxmlformats.org/drawingml/2006/main">
               <a:ext uri="{FF2B5EF4-FFF2-40B4-BE49-F238E27FC236}">
-                <a16:creationId xmlns:a16="http://schemas.microsoft.com/office/drawing/2014/main" id="{4AD75170-E200-49D9-A3C1-6AB6C594AD7D}"/>
+                <a16:creationId xmlns:a16="http://schemas.microsoft.com/office/drawing/2014/main" id="{C818E893-22E1-4F1B-8885-1A9D5C58B5B1}"/>
               </a:ext>
             </a:extLst>
           </p:cNvPr>
@@ -3911,7 +3911,7 @@
     </p:spTree>
     <p:extLst>
       <p:ext uri="{BB962C8B-B14F-4D97-AF65-F5344CB8AC3E}">
-        <p14:creationId xmlns:p14="http://schemas.microsoft.com/office/powerpoint/2010/main" val="1578137549"/>
+        <p14:creationId xmlns:p14="http://schemas.microsoft.com/office/powerpoint/2010/main" val="1907187764"/>
       </p:ext>
     </p:extLst>
   </p:cSld>
@@ -3942,7 +3942,7 @@
           <p:cNvPr id="8" name="">
             <a:extLst xmlns:a="http://schemas.openxmlformats.org/drawingml/2006/main">
               <a:ext uri="{FF2B5EF4-FFF2-40B4-BE49-F238E27FC236}">
-                <a16:creationId xmlns:a16="http://schemas.microsoft.com/office/drawing/2014/main" id="{BFDC390C-75E4-4D08-9BAB-6968BE7085F5}"/>
+                <a16:creationId xmlns:a16="http://schemas.microsoft.com/office/drawing/2014/main" id="{647CA142-B04B-4208-B6B7-B55E28AD0F50}"/>
               </a:ext>
             </a:extLst>
           </p:cNvPr>
@@ -3999,7 +3999,7 @@
           <p:cNvPr id="2" name="">
             <a:extLst xmlns:a="http://schemas.openxmlformats.org/drawingml/2006/main">
               <a:ext uri="{FF2B5EF4-FFF2-40B4-BE49-F238E27FC236}">
-                <a16:creationId xmlns:a16="http://schemas.microsoft.com/office/drawing/2014/main" id="{03138CB9-1AFC-4AEF-B190-7772C5AF80A6}"/>
+                <a16:creationId xmlns:a16="http://schemas.microsoft.com/office/drawing/2014/main" id="{279962F9-A159-40BF-A29D-3AD0E9B26113}"/>
               </a:ext>
             </a:extLst>
           </p:cNvPr>
@@ -4056,7 +4056,7 @@
           <p:cNvPr id="3" name="">
             <a:extLst xmlns:a="http://schemas.openxmlformats.org/drawingml/2006/main">
               <a:ext uri="{FF2B5EF4-FFF2-40B4-BE49-F238E27FC236}">
-                <a16:creationId xmlns:a16="http://schemas.microsoft.com/office/drawing/2014/main" id="{1BCE2517-1B7F-469C-8229-02F1E8231D8E}"/>
+                <a16:creationId xmlns:a16="http://schemas.microsoft.com/office/drawing/2014/main" id="{2C64267A-7CA6-490A-AA95-07E3457FD4C8}"/>
               </a:ext>
             </a:extLst>
           </p:cNvPr>
@@ -4113,7 +4113,7 @@
           <p:cNvPr id="4" name="">
             <a:extLst xmlns:a="http://schemas.openxmlformats.org/drawingml/2006/main">
               <a:ext uri="{FF2B5EF4-FFF2-40B4-BE49-F238E27FC236}">
-                <a16:creationId xmlns:a16="http://schemas.microsoft.com/office/drawing/2014/main" id="{1BEC4FCF-3353-4186-B640-FF44B5E9B883}"/>
+                <a16:creationId xmlns:a16="http://schemas.microsoft.com/office/drawing/2014/main" id="{6E3EB7F0-BCD8-440E-9799-C47DB7AF4923}"/>
               </a:ext>
             </a:extLst>
           </p:cNvPr>
@@ -4170,7 +4170,7 @@
           <p:cNvPr id="5" name="">
             <a:extLst xmlns:a="http://schemas.openxmlformats.org/drawingml/2006/main">
               <a:ext uri="{FF2B5EF4-FFF2-40B4-BE49-F238E27FC236}">
-                <a16:creationId xmlns:a16="http://schemas.microsoft.com/office/drawing/2014/main" id="{F7C96FAF-7658-46A0-AE37-7E5DF79A1B0B}"/>
+                <a16:creationId xmlns:a16="http://schemas.microsoft.com/office/drawing/2014/main" id="{352ADB71-BE0B-466A-BDC6-0644422DC95B}"/>
               </a:ext>
             </a:extLst>
           </p:cNvPr>
@@ -4227,7 +4227,7 @@
           <p:cNvPr id="6" name="">
             <a:extLst xmlns:a="http://schemas.openxmlformats.org/drawingml/2006/main">
               <a:ext uri="{FF2B5EF4-FFF2-40B4-BE49-F238E27FC236}">
-                <a16:creationId xmlns:a16="http://schemas.microsoft.com/office/drawing/2014/main" id="{D5A2BDD1-4781-4E06-94CF-B6BD2BF0D115}"/>
+                <a16:creationId xmlns:a16="http://schemas.microsoft.com/office/drawing/2014/main" id="{6CE2C230-2BC6-4B73-8848-103BD8742475}"/>
               </a:ext>
             </a:extLst>
           </p:cNvPr>
@@ -4288,7 +4288,7 @@
           <p:nvPr/>
         </p:nvPicPr>
         <p:blipFill>
-          <a:blip xmlns:r="http://schemas.openxmlformats.org/officeDocument/2006/relationships" xmlns:a="http://schemas.openxmlformats.org/drawingml/2006/main" r:embed="Rf352dcb1b8834952"/>
+          <a:blip xmlns:r="http://schemas.openxmlformats.org/officeDocument/2006/relationships" xmlns:a="http://schemas.openxmlformats.org/drawingml/2006/main" r:embed="R0f652d94067f452f"/>
           <a:stretch xmlns:a="http://schemas.openxmlformats.org/drawingml/2006/main"/>
         </p:blipFill>
         <p:spPr>
@@ -4304,7 +4304,7 @@
     </p:spTree>
     <p:extLst>
       <p:ext uri="{BB962C8B-B14F-4D97-AF65-F5344CB8AC3E}">
-        <p14:creationId xmlns:p14="http://schemas.microsoft.com/office/powerpoint/2010/main" val="336518801"/>
+        <p14:creationId xmlns:p14="http://schemas.microsoft.com/office/powerpoint/2010/main" val="631172156"/>
       </p:ext>
     </p:extLst>
   </p:cSld>
@@ -4335,7 +4335,7 @@
           <p:cNvPr id="10" name="">
             <a:extLst xmlns:a="http://schemas.openxmlformats.org/drawingml/2006/main">
               <a:ext uri="{FF2B5EF4-FFF2-40B4-BE49-F238E27FC236}">
-                <a16:creationId xmlns:a16="http://schemas.microsoft.com/office/drawing/2014/main" id="{6B82559C-4509-4FDA-B2B3-BBE882C0F4EB}"/>
+                <a16:creationId xmlns:a16="http://schemas.microsoft.com/office/drawing/2014/main" id="{3B8C00F7-B9CF-44EC-A0BE-2B62D54B6756}"/>
               </a:ext>
             </a:extLst>
           </p:cNvPr>
@@ -4392,7 +4392,7 @@
           <p:cNvPr id="2" name="">
             <a:extLst xmlns:a="http://schemas.openxmlformats.org/drawingml/2006/main">
               <a:ext uri="{FF2B5EF4-FFF2-40B4-BE49-F238E27FC236}">
-                <a16:creationId xmlns:a16="http://schemas.microsoft.com/office/drawing/2014/main" id="{C8C4D912-912E-4158-BA75-5C9938233426}"/>
+                <a16:creationId xmlns:a16="http://schemas.microsoft.com/office/drawing/2014/main" id="{36BBD95F-C5FB-43DE-8892-EC4833A4C327}"/>
               </a:ext>
             </a:extLst>
           </p:cNvPr>
@@ -4449,7 +4449,7 @@
           <p:cNvPr id="3" name="">
             <a:extLst xmlns:a="http://schemas.openxmlformats.org/drawingml/2006/main">
               <a:ext uri="{FF2B5EF4-FFF2-40B4-BE49-F238E27FC236}">
-                <a16:creationId xmlns:a16="http://schemas.microsoft.com/office/drawing/2014/main" id="{C6BE77BF-A410-44A9-B3E9-404CBC6898DD}"/>
+                <a16:creationId xmlns:a16="http://schemas.microsoft.com/office/drawing/2014/main" id="{082BE388-0A1A-40C1-BBCB-463215F04FD6}"/>
               </a:ext>
             </a:extLst>
           </p:cNvPr>
@@ -4506,7 +4506,7 @@
           <p:cNvPr id="4" name="">
             <a:extLst xmlns:a="http://schemas.openxmlformats.org/drawingml/2006/main">
               <a:ext uri="{FF2B5EF4-FFF2-40B4-BE49-F238E27FC236}">
-                <a16:creationId xmlns:a16="http://schemas.microsoft.com/office/drawing/2014/main" id="{520116F6-3134-4890-B849-2E5BA69FCCFD}"/>
+                <a16:creationId xmlns:a16="http://schemas.microsoft.com/office/drawing/2014/main" id="{DCD3ACB4-6139-4BC1-91D1-9FD1740AA1AA}"/>
               </a:ext>
             </a:extLst>
           </p:cNvPr>
@@ -4563,7 +4563,7 @@
           <p:cNvPr id="5" name="">
             <a:extLst xmlns:a="http://schemas.openxmlformats.org/drawingml/2006/main">
               <a:ext uri="{FF2B5EF4-FFF2-40B4-BE49-F238E27FC236}">
-                <a16:creationId xmlns:a16="http://schemas.microsoft.com/office/drawing/2014/main" id="{A1C3ED10-2916-4C6C-80F8-8F9C55F4171F}"/>
+                <a16:creationId xmlns:a16="http://schemas.microsoft.com/office/drawing/2014/main" id="{BEAEA192-A1BD-4074-ACDA-B9CACE1CA59A}"/>
               </a:ext>
             </a:extLst>
           </p:cNvPr>
@@ -4643,7 +4643,7 @@
           <p:cNvPr id="6" name="">
             <a:extLst xmlns:a="http://schemas.openxmlformats.org/drawingml/2006/main">
               <a:ext uri="{FF2B5EF4-FFF2-40B4-BE49-F238E27FC236}">
-                <a16:creationId xmlns:a16="http://schemas.microsoft.com/office/drawing/2014/main" id="{44E5204F-C939-4063-B3FE-9925FA132653}"/>
+                <a16:creationId xmlns:a16="http://schemas.microsoft.com/office/drawing/2014/main" id="{56314DF3-45F8-4559-AC9E-0C098A7C97DE}"/>
               </a:ext>
             </a:extLst>
           </p:cNvPr>
@@ -4700,7 +4700,7 @@
           <p:cNvPr id="7" name="">
             <a:extLst xmlns:a="http://schemas.openxmlformats.org/drawingml/2006/main">
               <a:ext uri="{FF2B5EF4-FFF2-40B4-BE49-F238E27FC236}">
-                <a16:creationId xmlns:a16="http://schemas.microsoft.com/office/drawing/2014/main" id="{C007F704-19A9-44AD-A5E4-301CE3844F45}"/>
+                <a16:creationId xmlns:a16="http://schemas.microsoft.com/office/drawing/2014/main" id="{A3C194C8-B1AC-492E-874F-EB16E4777C10}"/>
               </a:ext>
             </a:extLst>
           </p:cNvPr>
@@ -4780,7 +4780,7 @@
           <p:cNvPr id="8" name="">
             <a:extLst xmlns:a="http://schemas.openxmlformats.org/drawingml/2006/main">
               <a:ext uri="{FF2B5EF4-FFF2-40B4-BE49-F238E27FC236}">
-                <a16:creationId xmlns:a16="http://schemas.microsoft.com/office/drawing/2014/main" id="{EF2FD267-A22A-4C93-B27E-C697B09A57E2}"/>
+                <a16:creationId xmlns:a16="http://schemas.microsoft.com/office/drawing/2014/main" id="{3FE806B2-D8ED-41D7-803E-B998F66BB67B}"/>
               </a:ext>
             </a:extLst>
           </p:cNvPr>
@@ -4837,7 +4837,7 @@
           <p:cNvPr id="9" name="">
             <a:extLst xmlns:a="http://schemas.openxmlformats.org/drawingml/2006/main">
               <a:ext uri="{FF2B5EF4-FFF2-40B4-BE49-F238E27FC236}">
-                <a16:creationId xmlns:a16="http://schemas.microsoft.com/office/drawing/2014/main" id="{98E7B52F-3CBD-4182-A982-8F9BFF0B5849}"/>
+                <a16:creationId xmlns:a16="http://schemas.microsoft.com/office/drawing/2014/main" id="{966B32DC-7EB2-4DA2-9E84-7A357F0A319B}"/>
               </a:ext>
             </a:extLst>
           </p:cNvPr>
@@ -4892,7 +4892,7 @@
     </p:spTree>
     <p:extLst>
       <p:ext uri="{BB962C8B-B14F-4D97-AF65-F5344CB8AC3E}">
-        <p14:creationId xmlns:p14="http://schemas.microsoft.com/office/powerpoint/2010/main" val="2041117286"/>
+        <p14:creationId xmlns:p14="http://schemas.microsoft.com/office/powerpoint/2010/main" val="730222847"/>
       </p:ext>
     </p:extLst>
   </p:cSld>
@@ -4923,7 +4923,7 @@
           <p:cNvPr id="9" name="">
             <a:extLst xmlns:a="http://schemas.openxmlformats.org/drawingml/2006/main">
               <a:ext uri="{FF2B5EF4-FFF2-40B4-BE49-F238E27FC236}">
-                <a16:creationId xmlns:a16="http://schemas.microsoft.com/office/drawing/2014/main" id="{812B2A08-9B6C-4EED-B542-D7D9AF15C859}"/>
+                <a16:creationId xmlns:a16="http://schemas.microsoft.com/office/drawing/2014/main" id="{003942B7-3494-4B98-8D64-2674700AAAE4}"/>
               </a:ext>
             </a:extLst>
           </p:cNvPr>
@@ -4980,7 +4980,7 @@
           <p:cNvPr id="2" name="">
             <a:extLst xmlns:a="http://schemas.openxmlformats.org/drawingml/2006/main">
               <a:ext uri="{FF2B5EF4-FFF2-40B4-BE49-F238E27FC236}">
-                <a16:creationId xmlns:a16="http://schemas.microsoft.com/office/drawing/2014/main" id="{71B1C975-7884-4A5C-A055-CF34D08BAC4E}"/>
+                <a16:creationId xmlns:a16="http://schemas.microsoft.com/office/drawing/2014/main" id="{F456B043-A823-48A0-973B-AC7E3BB40ECD}"/>
               </a:ext>
             </a:extLst>
           </p:cNvPr>
@@ -5037,7 +5037,7 @@
           <p:cNvPr id="3" name="">
             <a:extLst xmlns:a="http://schemas.openxmlformats.org/drawingml/2006/main">
               <a:ext uri="{FF2B5EF4-FFF2-40B4-BE49-F238E27FC236}">
-                <a16:creationId xmlns:a16="http://schemas.microsoft.com/office/drawing/2014/main" id="{963ACADC-D4E8-4D77-B2B0-C58FD37F5ACB}"/>
+                <a16:creationId xmlns:a16="http://schemas.microsoft.com/office/drawing/2014/main" id="{7FC38C6D-A50A-486C-A428-3CB5BF3808C5}"/>
               </a:ext>
             </a:extLst>
           </p:cNvPr>
@@ -5094,7 +5094,7 @@
           <p:cNvPr id="4" name="">
             <a:extLst xmlns:a="http://schemas.openxmlformats.org/drawingml/2006/main">
               <a:ext uri="{FF2B5EF4-FFF2-40B4-BE49-F238E27FC236}">
-                <a16:creationId xmlns:a16="http://schemas.microsoft.com/office/drawing/2014/main" id="{124EB034-8A06-43C4-931C-14A0F3F017D7}"/>
+                <a16:creationId xmlns:a16="http://schemas.microsoft.com/office/drawing/2014/main" id="{0D324E85-3699-4ECC-99D6-D4CA8AECCF55}"/>
               </a:ext>
             </a:extLst>
           </p:cNvPr>
@@ -5151,7 +5151,7 @@
           <p:cNvPr id="5" name="">
             <a:extLst xmlns:a="http://schemas.openxmlformats.org/drawingml/2006/main">
               <a:ext uri="{FF2B5EF4-FFF2-40B4-BE49-F238E27FC236}">
-                <a16:creationId xmlns:a16="http://schemas.microsoft.com/office/drawing/2014/main" id="{2EFCEE79-D740-44E5-BCFB-5CD38426E78B}"/>
+                <a16:creationId xmlns:a16="http://schemas.microsoft.com/office/drawing/2014/main" id="{B0631133-E9D5-4FE9-AD95-4C06C370A97F}"/>
               </a:ext>
             </a:extLst>
           </p:cNvPr>
@@ -5208,7 +5208,7 @@
           <p:cNvPr id="6" name="">
             <a:extLst xmlns:a="http://schemas.openxmlformats.org/drawingml/2006/main">
               <a:ext uri="{FF2B5EF4-FFF2-40B4-BE49-F238E27FC236}">
-                <a16:creationId xmlns:a16="http://schemas.microsoft.com/office/drawing/2014/main" id="{F18D24C6-ADF1-476B-B4EC-10C9FAE34B6E}"/>
+                <a16:creationId xmlns:a16="http://schemas.microsoft.com/office/drawing/2014/main" id="{AFB4A89F-D892-4C11-86E4-C0D1CA5E4683}"/>
               </a:ext>
             </a:extLst>
           </p:cNvPr>
@@ -5255,7 +5255,7 @@
                 <a:ea typeface="Arial"/>
                 <a:cs typeface="Arial"/>
               </a:rPr>
-              <a:t>101 тест</a:t>
+              <a:t>100+ тестов</a:t>
             </a:r>
           </a:p>
         </p:txBody>
@@ -5265,7 +5265,7 @@
           <p:cNvPr id="7" name="">
             <a:extLst xmlns:a="http://schemas.openxmlformats.org/drawingml/2006/main">
               <a:ext uri="{FF2B5EF4-FFF2-40B4-BE49-F238E27FC236}">
-                <a16:creationId xmlns:a16="http://schemas.microsoft.com/office/drawing/2014/main" id="{827829EE-480A-418C-865D-AD58F1211A3E}"/>
+                <a16:creationId xmlns:a16="http://schemas.microsoft.com/office/drawing/2014/main" id="{3914DE34-D1A9-4881-A51C-DACC0B7B39C2}"/>
               </a:ext>
             </a:extLst>
           </p:cNvPr>
@@ -5322,7 +5322,7 @@
           <p:cNvPr id="8" name="">
             <a:extLst xmlns:a="http://schemas.openxmlformats.org/drawingml/2006/main">
               <a:ext uri="{FF2B5EF4-FFF2-40B4-BE49-F238E27FC236}">
-                <a16:creationId xmlns:a16="http://schemas.microsoft.com/office/drawing/2014/main" id="{EF4F59B6-AF95-4FC5-AF94-4AC388656942}"/>
+                <a16:creationId xmlns:a16="http://schemas.microsoft.com/office/drawing/2014/main" id="{82B5C4D6-F13A-488C-B446-8DFD679453AF}"/>
               </a:ext>
             </a:extLst>
           </p:cNvPr>
@@ -5377,7 +5377,7 @@
     </p:spTree>
     <p:extLst>
       <p:ext uri="{BB962C8B-B14F-4D97-AF65-F5344CB8AC3E}">
-        <p14:creationId xmlns:p14="http://schemas.microsoft.com/office/powerpoint/2010/main" val="323511805"/>
+        <p14:creationId xmlns:p14="http://schemas.microsoft.com/office/powerpoint/2010/main" val="1389238457"/>
       </p:ext>
     </p:extLst>
   </p:cSld>
@@ -5408,7 +5408,7 @@
           <p:cNvPr id="11" name="">
             <a:extLst xmlns:a="http://schemas.openxmlformats.org/drawingml/2006/main">
               <a:ext uri="{FF2B5EF4-FFF2-40B4-BE49-F238E27FC236}">
-                <a16:creationId xmlns:a16="http://schemas.microsoft.com/office/drawing/2014/main" id="{BE405EE0-D53B-42EB-8311-E8442640137B}"/>
+                <a16:creationId xmlns:a16="http://schemas.microsoft.com/office/drawing/2014/main" id="{880988A1-7F70-4414-B0AD-1CFB32F2BBEF}"/>
               </a:ext>
             </a:extLst>
           </p:cNvPr>
@@ -5465,7 +5465,7 @@
           <p:cNvPr id="2" name="">
             <a:extLst xmlns:a="http://schemas.openxmlformats.org/drawingml/2006/main">
               <a:ext uri="{FF2B5EF4-FFF2-40B4-BE49-F238E27FC236}">
-                <a16:creationId xmlns:a16="http://schemas.microsoft.com/office/drawing/2014/main" id="{29B41F51-A898-453E-87DF-3C8452D0226A}"/>
+                <a16:creationId xmlns:a16="http://schemas.microsoft.com/office/drawing/2014/main" id="{FCA7809D-2020-477E-A348-DF88C3704990}"/>
               </a:ext>
             </a:extLst>
           </p:cNvPr>
@@ -5522,7 +5522,7 @@
           <p:cNvPr id="3" name="">
             <a:extLst xmlns:a="http://schemas.openxmlformats.org/drawingml/2006/main">
               <a:ext uri="{FF2B5EF4-FFF2-40B4-BE49-F238E27FC236}">
-                <a16:creationId xmlns:a16="http://schemas.microsoft.com/office/drawing/2014/main" id="{1CBF2000-025D-473A-9209-687266FF8D32}"/>
+                <a16:creationId xmlns:a16="http://schemas.microsoft.com/office/drawing/2014/main" id="{E9A4D936-B44E-4090-B7EA-BF3E56EC68DF}"/>
               </a:ext>
             </a:extLst>
           </p:cNvPr>
@@ -5579,7 +5579,7 @@
           <p:cNvPr id="4" name="">
             <a:extLst xmlns:a="http://schemas.openxmlformats.org/drawingml/2006/main">
               <a:ext uri="{FF2B5EF4-FFF2-40B4-BE49-F238E27FC236}">
-                <a16:creationId xmlns:a16="http://schemas.microsoft.com/office/drawing/2014/main" id="{03C6A2D0-F80D-4B8E-8102-4AA1841496A4}"/>
+                <a16:creationId xmlns:a16="http://schemas.microsoft.com/office/drawing/2014/main" id="{CF9A2787-716D-4C6C-AF0E-85B4C0751DDB}"/>
               </a:ext>
             </a:extLst>
           </p:cNvPr>
@@ -5636,7 +5636,7 @@
           <p:cNvPr id="5" name="">
             <a:extLst xmlns:a="http://schemas.openxmlformats.org/drawingml/2006/main">
               <a:ext uri="{FF2B5EF4-FFF2-40B4-BE49-F238E27FC236}">
-                <a16:creationId xmlns:a16="http://schemas.microsoft.com/office/drawing/2014/main" id="{A7A11136-B4CB-41EE-B926-E1BDE4B3AD69}"/>
+                <a16:creationId xmlns:a16="http://schemas.microsoft.com/office/drawing/2014/main" id="{01B49F38-F402-4D77-B771-6C4BBD7E49FC}"/>
               </a:ext>
             </a:extLst>
           </p:cNvPr>
@@ -5693,7 +5693,7 @@
           <p:cNvPr id="6" name="">
             <a:extLst xmlns:a="http://schemas.openxmlformats.org/drawingml/2006/main">
               <a:ext uri="{FF2B5EF4-FFF2-40B4-BE49-F238E27FC236}">
-                <a16:creationId xmlns:a16="http://schemas.microsoft.com/office/drawing/2014/main" id="{629824F6-8A1F-4904-8FF7-CE18200DA7E0}"/>
+                <a16:creationId xmlns:a16="http://schemas.microsoft.com/office/drawing/2014/main" id="{B646EC94-F4C6-4CCB-8348-59554D57827C}"/>
               </a:ext>
             </a:extLst>
           </p:cNvPr>
@@ -5750,7 +5750,7 @@
           <p:cNvPr id="7" name="">
             <a:extLst xmlns:a="http://schemas.openxmlformats.org/drawingml/2006/main">
               <a:ext uri="{FF2B5EF4-FFF2-40B4-BE49-F238E27FC236}">
-                <a16:creationId xmlns:a16="http://schemas.microsoft.com/office/drawing/2014/main" id="{CE29BE48-0914-4810-8827-ABFB028063BB}"/>
+                <a16:creationId xmlns:a16="http://schemas.microsoft.com/office/drawing/2014/main" id="{86C62E1F-D676-4BF5-A4CD-D586513425CD}"/>
               </a:ext>
             </a:extLst>
           </p:cNvPr>
@@ -5807,7 +5807,7 @@
           <p:cNvPr id="8" name="">
             <a:extLst xmlns:a="http://schemas.openxmlformats.org/drawingml/2006/main">
               <a:ext uri="{FF2B5EF4-FFF2-40B4-BE49-F238E27FC236}">
-                <a16:creationId xmlns:a16="http://schemas.microsoft.com/office/drawing/2014/main" id="{DCE2F49A-4534-473D-B501-2AA7A7393514}"/>
+                <a16:creationId xmlns:a16="http://schemas.microsoft.com/office/drawing/2014/main" id="{800858D9-55D5-4F80-8EB3-1E37029A6137}"/>
               </a:ext>
             </a:extLst>
           </p:cNvPr>
@@ -5864,7 +5864,7 @@
           <p:cNvPr id="9" name="">
             <a:extLst xmlns:a="http://schemas.openxmlformats.org/drawingml/2006/main">
               <a:ext uri="{FF2B5EF4-FFF2-40B4-BE49-F238E27FC236}">
-                <a16:creationId xmlns:a16="http://schemas.microsoft.com/office/drawing/2014/main" id="{E30823A1-CE80-44F2-B33C-4FCFF87343F0}"/>
+                <a16:creationId xmlns:a16="http://schemas.microsoft.com/office/drawing/2014/main" id="{BA9B3E15-1A51-45A9-8713-E14E06AC12E5}"/>
               </a:ext>
             </a:extLst>
           </p:cNvPr>
@@ -5921,7 +5921,7 @@
           <p:cNvPr id="10" name="">
             <a:extLst xmlns:a="http://schemas.openxmlformats.org/drawingml/2006/main">
               <a:ext uri="{FF2B5EF4-FFF2-40B4-BE49-F238E27FC236}">
-                <a16:creationId xmlns:a16="http://schemas.microsoft.com/office/drawing/2014/main" id="{C85B1102-75BA-487F-80E3-0A1AF604062E}"/>
+                <a16:creationId xmlns:a16="http://schemas.microsoft.com/office/drawing/2014/main" id="{7B0F8F07-332C-4A91-8A13-FE7B6C533046}"/>
               </a:ext>
             </a:extLst>
           </p:cNvPr>
@@ -5976,7 +5976,7 @@
     </p:spTree>
     <p:extLst>
       <p:ext uri="{BB962C8B-B14F-4D97-AF65-F5344CB8AC3E}">
-        <p14:creationId xmlns:p14="http://schemas.microsoft.com/office/powerpoint/2010/main" val="2130533415"/>
+        <p14:creationId xmlns:p14="http://schemas.microsoft.com/office/powerpoint/2010/main" val="218718184"/>
       </p:ext>
     </p:extLst>
   </p:cSld>

</xml_diff>